<commit_message>
update media and slide
</commit_message>
<xml_diff>
--- a/Media/Figure.pptx
+++ b/Media/Figure.pptx
@@ -269,7 +269,7 @@
           <a:p>
             <a:fld id="{7959E98B-ABE6-5D43-AAFE-9F5C8C770207}" type="datetimeFigureOut">
               <a:rPr lang="en-VN" smtClean="0"/>
-              <a:t>30/06/2024</a:t>
+              <a:t>05/07/2024</a:t>
             </a:fld>
             <a:endParaRPr lang="en-VN"/>
           </a:p>
@@ -469,7 +469,7 @@
           <a:p>
             <a:fld id="{7959E98B-ABE6-5D43-AAFE-9F5C8C770207}" type="datetimeFigureOut">
               <a:rPr lang="en-VN" smtClean="0"/>
-              <a:t>30/06/2024</a:t>
+              <a:t>05/07/2024</a:t>
             </a:fld>
             <a:endParaRPr lang="en-VN"/>
           </a:p>
@@ -679,7 +679,7 @@
           <a:p>
             <a:fld id="{7959E98B-ABE6-5D43-AAFE-9F5C8C770207}" type="datetimeFigureOut">
               <a:rPr lang="en-VN" smtClean="0"/>
-              <a:t>30/06/2024</a:t>
+              <a:t>05/07/2024</a:t>
             </a:fld>
             <a:endParaRPr lang="en-VN"/>
           </a:p>
@@ -879,7 +879,7 @@
           <a:p>
             <a:fld id="{7959E98B-ABE6-5D43-AAFE-9F5C8C770207}" type="datetimeFigureOut">
               <a:rPr lang="en-VN" smtClean="0"/>
-              <a:t>30/06/2024</a:t>
+              <a:t>05/07/2024</a:t>
             </a:fld>
             <a:endParaRPr lang="en-VN"/>
           </a:p>
@@ -1155,7 +1155,7 @@
           <a:p>
             <a:fld id="{7959E98B-ABE6-5D43-AAFE-9F5C8C770207}" type="datetimeFigureOut">
               <a:rPr lang="en-VN" smtClean="0"/>
-              <a:t>30/06/2024</a:t>
+              <a:t>05/07/2024</a:t>
             </a:fld>
             <a:endParaRPr lang="en-VN"/>
           </a:p>
@@ -1423,7 +1423,7 @@
           <a:p>
             <a:fld id="{7959E98B-ABE6-5D43-AAFE-9F5C8C770207}" type="datetimeFigureOut">
               <a:rPr lang="en-VN" smtClean="0"/>
-              <a:t>30/06/2024</a:t>
+              <a:t>05/07/2024</a:t>
             </a:fld>
             <a:endParaRPr lang="en-VN"/>
           </a:p>
@@ -1838,7 +1838,7 @@
           <a:p>
             <a:fld id="{7959E98B-ABE6-5D43-AAFE-9F5C8C770207}" type="datetimeFigureOut">
               <a:rPr lang="en-VN" smtClean="0"/>
-              <a:t>30/06/2024</a:t>
+              <a:t>05/07/2024</a:t>
             </a:fld>
             <a:endParaRPr lang="en-VN"/>
           </a:p>
@@ -1980,7 +1980,7 @@
           <a:p>
             <a:fld id="{7959E98B-ABE6-5D43-AAFE-9F5C8C770207}" type="datetimeFigureOut">
               <a:rPr lang="en-VN" smtClean="0"/>
-              <a:t>30/06/2024</a:t>
+              <a:t>05/07/2024</a:t>
             </a:fld>
             <a:endParaRPr lang="en-VN"/>
           </a:p>
@@ -2093,7 +2093,7 @@
           <a:p>
             <a:fld id="{7959E98B-ABE6-5D43-AAFE-9F5C8C770207}" type="datetimeFigureOut">
               <a:rPr lang="en-VN" smtClean="0"/>
-              <a:t>30/06/2024</a:t>
+              <a:t>05/07/2024</a:t>
             </a:fld>
             <a:endParaRPr lang="en-VN"/>
           </a:p>
@@ -2406,7 +2406,7 @@
           <a:p>
             <a:fld id="{7959E98B-ABE6-5D43-AAFE-9F5C8C770207}" type="datetimeFigureOut">
               <a:rPr lang="en-VN" smtClean="0"/>
-              <a:t>30/06/2024</a:t>
+              <a:t>05/07/2024</a:t>
             </a:fld>
             <a:endParaRPr lang="en-VN"/>
           </a:p>
@@ -2695,7 +2695,7 @@
           <a:p>
             <a:fld id="{7959E98B-ABE6-5D43-AAFE-9F5C8C770207}" type="datetimeFigureOut">
               <a:rPr lang="en-VN" smtClean="0"/>
-              <a:t>30/06/2024</a:t>
+              <a:t>05/07/2024</a:t>
             </a:fld>
             <a:endParaRPr lang="en-VN"/>
           </a:p>
@@ -2938,7 +2938,7 @@
           <a:p>
             <a:fld id="{7959E98B-ABE6-5D43-AAFE-9F5C8C770207}" type="datetimeFigureOut">
               <a:rPr lang="en-VN" smtClean="0"/>
-              <a:t>30/06/2024</a:t>
+              <a:t>05/07/2024</a:t>
             </a:fld>
             <a:endParaRPr lang="en-VN"/>
           </a:p>

</xml_diff>